<commit_message>
Updated the Presenation slides
</commit_message>
<xml_diff>
--- a/Presentation.pptx
+++ b/Presentation.pptx
@@ -2497,7 +2497,7 @@
           </a:prstGeom>
           <a:extLst>
             <a:ext uri="{C572A759-6A51-4108-AA02-DFA0A04FC94B}">
-              <ma14:wrappingTextBoxFlag xmlns="" xmlns:ma14="http://schemas.microsoft.com/office/mac/drawingml/2011/main" val="0"/>
+              <ma14:wrappingTextBoxFlag xmlns:ma14="http://schemas.microsoft.com/office/mac/drawingml/2011/main" xmlns="" val="0"/>
             </a:ext>
           </a:extLst>
         </p:spPr>
@@ -2572,7 +2572,7 @@
           </a:prstGeom>
           <a:extLst>
             <a:ext uri="{C572A759-6A51-4108-AA02-DFA0A04FC94B}">
-              <ma14:wrappingTextBoxFlag xmlns="" xmlns:ma14="http://schemas.microsoft.com/office/mac/drawingml/2011/main" val="0"/>
+              <ma14:wrappingTextBoxFlag xmlns:ma14="http://schemas.microsoft.com/office/mac/drawingml/2011/main" xmlns="" val="0"/>
             </a:ext>
           </a:extLst>
         </p:spPr>
@@ -3650,7 +3650,7 @@
           </a:prstGeom>
           <a:extLst>
             <a:ext uri="{C572A759-6A51-4108-AA02-DFA0A04FC94B}">
-              <ma14:wrappingTextBoxFlag xmlns="" xmlns:ma14="http://schemas.microsoft.com/office/mac/drawingml/2011/main" val="0"/>
+              <ma14:wrappingTextBoxFlag xmlns:ma14="http://schemas.microsoft.com/office/mac/drawingml/2011/main" xmlns="" val="0"/>
             </a:ext>
           </a:extLst>
         </p:spPr>
@@ -3921,7 +3921,7 @@
           </a:prstGeom>
           <a:extLst>
             <a:ext uri="{C572A759-6A51-4108-AA02-DFA0A04FC94B}">
-              <ma14:wrappingTextBoxFlag xmlns="" xmlns:ma14="http://schemas.microsoft.com/office/mac/drawingml/2011/main" val="0"/>
+              <ma14:wrappingTextBoxFlag xmlns:ma14="http://schemas.microsoft.com/office/mac/drawingml/2011/main" xmlns="" val="0"/>
             </a:ext>
           </a:extLst>
         </p:spPr>
@@ -4993,7 +4993,7 @@
           </a:prstGeom>
           <a:extLst>
             <a:ext uri="{C572A759-6A51-4108-AA02-DFA0A04FC94B}">
-              <ma14:wrappingTextBoxFlag xmlns="" xmlns:ma14="http://schemas.microsoft.com/office/mac/drawingml/2011/main" val="0"/>
+              <ma14:wrappingTextBoxFlag xmlns:ma14="http://schemas.microsoft.com/office/mac/drawingml/2011/main" xmlns="" val="0"/>
             </a:ext>
           </a:extLst>
         </p:spPr>
@@ -5229,7 +5229,7 @@
           </a:prstGeom>
           <a:extLst>
             <a:ext uri="{C572A759-6A51-4108-AA02-DFA0A04FC94B}">
-              <ma14:wrappingTextBoxFlag xmlns="" xmlns:ma14="http://schemas.microsoft.com/office/mac/drawingml/2011/main" val="0"/>
+              <ma14:wrappingTextBoxFlag xmlns:ma14="http://schemas.microsoft.com/office/mac/drawingml/2011/main" xmlns="" val="0"/>
             </a:ext>
           </a:extLst>
         </p:spPr>
@@ -7733,7 +7733,7 @@
           </a:prstGeom>
           <a:extLst>
             <a:ext uri="{C572A759-6A51-4108-AA02-DFA0A04FC94B}">
-              <ma14:wrappingTextBoxFlag xmlns="" xmlns:ma14="http://schemas.microsoft.com/office/mac/drawingml/2011/main" val="0"/>
+              <ma14:wrappingTextBoxFlag xmlns:ma14="http://schemas.microsoft.com/office/mac/drawingml/2011/main" xmlns="" val="0"/>
             </a:ext>
           </a:extLst>
         </p:spPr>
@@ -8134,7 +8134,7 @@
           </a:prstGeom>
           <a:extLst>
             <a:ext uri="{C572A759-6A51-4108-AA02-DFA0A04FC94B}">
-              <ma14:wrappingTextBoxFlag xmlns="" xmlns:ma14="http://schemas.microsoft.com/office/mac/drawingml/2011/main" val="0"/>
+              <ma14:wrappingTextBoxFlag xmlns:ma14="http://schemas.microsoft.com/office/mac/drawingml/2011/main" xmlns="" val="0"/>
             </a:ext>
           </a:extLst>
         </p:spPr>
@@ -8391,7 +8391,7 @@
           </a:prstGeom>
           <a:extLst>
             <a:ext uri="{C572A759-6A51-4108-AA02-DFA0A04FC94B}">
-              <ma14:wrappingTextBoxFlag xmlns="" xmlns:ma14="http://schemas.microsoft.com/office/mac/drawingml/2011/main" val="0"/>
+              <ma14:wrappingTextBoxFlag xmlns:ma14="http://schemas.microsoft.com/office/mac/drawingml/2011/main" xmlns="" val="0"/>
             </a:ext>
           </a:extLst>
         </p:spPr>
@@ -9894,7 +9894,18 @@
                 <a:ea typeface="Calibri" pitchFamily="34" charset="-122"/>
                 <a:cs typeface="Calibri" pitchFamily="34" charset="-120"/>
               </a:rPr>
-              <a:t>Add captions, hashtags and account ids</a:t>
+              <a:t>Add captions, hashtags </a:t>
+            </a:r>
+            <a:r>
+              <a:rPr lang="en-US" sz="1400">
+                <a:solidFill>
+                  <a:srgbClr val="1B2A3F"/>
+                </a:solidFill>
+                <a:latin typeface="Calibri" pitchFamily="34" charset="0"/>
+                <a:ea typeface="Calibri" pitchFamily="34" charset="-122"/>
+                <a:cs typeface="Calibri" pitchFamily="34" charset="-120"/>
+              </a:rPr>
+              <a:t>and creator account IDs</a:t>
             </a:r>
             <a:endParaRPr lang="en-US" sz="1400" dirty="0"/>
           </a:p>
@@ -9941,7 +9952,7 @@
           </a:prstGeom>
           <a:extLst>
             <a:ext uri="{C572A759-6A51-4108-AA02-DFA0A04FC94B}">
-              <ma14:wrappingTextBoxFlag xmlns="" xmlns:ma14="http://schemas.microsoft.com/office/mac/drawingml/2011/main" val="0"/>
+              <ma14:wrappingTextBoxFlag xmlns:ma14="http://schemas.microsoft.com/office/mac/drawingml/2011/main" xmlns="" val="0"/>
             </a:ext>
           </a:extLst>
         </p:spPr>

</xml_diff>

<commit_message>
Updated the Presentation slides
</commit_message>
<xml_diff>
--- a/Presentation.pptx
+++ b/Presentation.pptx
@@ -2497,7 +2497,7 @@
           </a:prstGeom>
           <a:extLst>
             <a:ext uri="{C572A759-6A51-4108-AA02-DFA0A04FC94B}">
-              <ma14:wrappingTextBoxFlag xmlns:ma14="http://schemas.microsoft.com/office/mac/drawingml/2011/main" xmlns="" val="0"/>
+              <ma14:wrappingTextBoxFlag xmlns="" xmlns:ma14="http://schemas.microsoft.com/office/mac/drawingml/2011/main" val="0"/>
             </a:ext>
           </a:extLst>
         </p:spPr>
@@ -2572,7 +2572,7 @@
           </a:prstGeom>
           <a:extLst>
             <a:ext uri="{C572A759-6A51-4108-AA02-DFA0A04FC94B}">
-              <ma14:wrappingTextBoxFlag xmlns:ma14="http://schemas.microsoft.com/office/mac/drawingml/2011/main" xmlns="" val="0"/>
+              <ma14:wrappingTextBoxFlag xmlns="" xmlns:ma14="http://schemas.microsoft.com/office/mac/drawingml/2011/main" val="0"/>
             </a:ext>
           </a:extLst>
         </p:spPr>
@@ -2963,7 +2963,7 @@
         <p:spPr>
           <a:xfrm>
             <a:off x="548640" y="4206240"/>
-            <a:ext cx="4572000" cy="274320"/>
+            <a:ext cx="4486422" cy="274320"/>
           </a:xfrm>
           <a:prstGeom prst="rect">
             <a:avLst/>
@@ -3650,7 +3650,7 @@
           </a:prstGeom>
           <a:extLst>
             <a:ext uri="{C572A759-6A51-4108-AA02-DFA0A04FC94B}">
-              <ma14:wrappingTextBoxFlag xmlns:ma14="http://schemas.microsoft.com/office/mac/drawingml/2011/main" xmlns="" val="0"/>
+              <ma14:wrappingTextBoxFlag xmlns="" xmlns:ma14="http://schemas.microsoft.com/office/mac/drawingml/2011/main" val="0"/>
             </a:ext>
           </a:extLst>
         </p:spPr>
@@ -3921,7 +3921,7 @@
           </a:prstGeom>
           <a:extLst>
             <a:ext uri="{C572A759-6A51-4108-AA02-DFA0A04FC94B}">
-              <ma14:wrappingTextBoxFlag xmlns:ma14="http://schemas.microsoft.com/office/mac/drawingml/2011/main" xmlns="" val="0"/>
+              <ma14:wrappingTextBoxFlag xmlns="" xmlns:ma14="http://schemas.microsoft.com/office/mac/drawingml/2011/main" val="0"/>
             </a:ext>
           </a:extLst>
         </p:spPr>
@@ -4993,7 +4993,7 @@
           </a:prstGeom>
           <a:extLst>
             <a:ext uri="{C572A759-6A51-4108-AA02-DFA0A04FC94B}">
-              <ma14:wrappingTextBoxFlag xmlns:ma14="http://schemas.microsoft.com/office/mac/drawingml/2011/main" xmlns="" val="0"/>
+              <ma14:wrappingTextBoxFlag xmlns="" xmlns:ma14="http://schemas.microsoft.com/office/mac/drawingml/2011/main" val="0"/>
             </a:ext>
           </a:extLst>
         </p:spPr>
@@ -5229,7 +5229,7 @@
           </a:prstGeom>
           <a:extLst>
             <a:ext uri="{C572A759-6A51-4108-AA02-DFA0A04FC94B}">
-              <ma14:wrappingTextBoxFlag xmlns:ma14="http://schemas.microsoft.com/office/mac/drawingml/2011/main" xmlns="" val="0"/>
+              <ma14:wrappingTextBoxFlag xmlns="" xmlns:ma14="http://schemas.microsoft.com/office/mac/drawingml/2011/main" val="0"/>
             </a:ext>
           </a:extLst>
         </p:spPr>
@@ -7733,7 +7733,7 @@
           </a:prstGeom>
           <a:extLst>
             <a:ext uri="{C572A759-6A51-4108-AA02-DFA0A04FC94B}">
-              <ma14:wrappingTextBoxFlag xmlns:ma14="http://schemas.microsoft.com/office/mac/drawingml/2011/main" xmlns="" val="0"/>
+              <ma14:wrappingTextBoxFlag xmlns="" xmlns:ma14="http://schemas.microsoft.com/office/mac/drawingml/2011/main" val="0"/>
             </a:ext>
           </a:extLst>
         </p:spPr>
@@ -8134,7 +8134,7 @@
           </a:prstGeom>
           <a:extLst>
             <a:ext uri="{C572A759-6A51-4108-AA02-DFA0A04FC94B}">
-              <ma14:wrappingTextBoxFlag xmlns:ma14="http://schemas.microsoft.com/office/mac/drawingml/2011/main" xmlns="" val="0"/>
+              <ma14:wrappingTextBoxFlag xmlns="" xmlns:ma14="http://schemas.microsoft.com/office/mac/drawingml/2011/main" val="0"/>
             </a:ext>
           </a:extLst>
         </p:spPr>
@@ -8391,7 +8391,7 @@
           </a:prstGeom>
           <a:extLst>
             <a:ext uri="{C572A759-6A51-4108-AA02-DFA0A04FC94B}">
-              <ma14:wrappingTextBoxFlag xmlns:ma14="http://schemas.microsoft.com/office/mac/drawingml/2011/main" xmlns="" val="0"/>
+              <ma14:wrappingTextBoxFlag xmlns="" xmlns:ma14="http://schemas.microsoft.com/office/mac/drawingml/2011/main" val="0"/>
             </a:ext>
           </a:extLst>
         </p:spPr>
@@ -9952,7 +9952,7 @@
           </a:prstGeom>
           <a:extLst>
             <a:ext uri="{C572A759-6A51-4108-AA02-DFA0A04FC94B}">
-              <ma14:wrappingTextBoxFlag xmlns:ma14="http://schemas.microsoft.com/office/mac/drawingml/2011/main" xmlns="" val="0"/>
+              <ma14:wrappingTextBoxFlag xmlns="" xmlns:ma14="http://schemas.microsoft.com/office/mac/drawingml/2011/main" val="0"/>
             </a:ext>
           </a:extLst>
         </p:spPr>

</xml_diff>